<commit_message>
Ajusta quebra do título no slide de fechamento
Co-Authored-By: Claude Fable 5.1 <noreply@anthropic.com>
Claude-Session: https://claude.ai/code/session_01PdsmYxSMPP7HSkDtR6tasn
</commit_message>
<xml_diff>
--- a/apresentacao/lume-template.pptx
+++ b/apresentacao/lume-template.pptx
@@ -130,7 +130,7 @@
   <p:extLst>
     <p:ext uri="{521415D9-36F7-43E2-AB2F-B90AF26B5E84}">
       <p14:sectionLst xmlns:p14="http://schemas.microsoft.com/office/powerpoint/2010/main">
-        <p14:section name="Template · páginas em branco" id="{5c946a6a-5668-2ae0-5a35-137f768b2100}">
+        <p14:section name="Template · páginas em branco" id="{e4dbf07d-ca3b-cfb4-f6b6-e77ce511b9b0}">
           <p14:sldIdLst>
             <p14:sldId id="256"/>
             <p14:sldId id="257"/>
@@ -144,7 +144,7 @@
             <p14:sldId id="265"/>
           </p14:sldIdLst>
         </p14:section>
-        <p14:section name="Conteúdo da landing page" id="{7b2ca246-89a5-57ba-38ff-4b67f19d9c8f}">
+        <p14:section name="Conteúdo da landing page" id="{c8d4c059-9815-830e-92f1-0d144e7ceb32}">
           <p14:sldIdLst>
             <p14:sldId id="266"/>
             <p14:sldId id="267"/>
@@ -13011,7 +13011,21 @@
                   <a:srgbClr val="FBF8F4"/>
                 </a:solidFill>
               </a:rPr>
-              <a:t>Uma boa conversa todo dia para quem mora só</a:t>
+              <a:t>Uma boa conversa todo dia</a:t>
+            </a:r>
+            <a:endParaRPr lang="en-US" sz="3200" dirty="0"/>
+          </a:p>
+          <a:p>
+            <a:pPr algn="ctr" indent="0" marL="0">
+              <a:buNone/>
+            </a:pPr>
+            <a:r>
+              <a:rPr lang="en-US" sz="3200" dirty="0">
+                <a:solidFill>
+                  <a:srgbClr val="FBF8F4"/>
+                </a:solidFill>
+              </a:rPr>
+              <a:t>para quem mora só</a:t>
             </a:r>
             <a:endParaRPr lang="en-US" sz="3200" dirty="0"/>
           </a:p>

</xml_diff>